<commit_message>
Complete AI release notes capstone project: - Added Release Note Publisher skill - Added publish command - Updated workflow documentation - Added workflow diagram - Added demo video - Updated presentation - Added generated release notes, review report, Word and HTML outputs
</commit_message>
<xml_diff>
--- a/demo/AI-release-note-generation Team - Capstone Project_Bhargavi.pptx
+++ b/demo/AI-release-note-generation Team - Capstone Project_Bhargavi.pptx
@@ -7339,7 +7339,7 @@
           <p:nvPr>
             <p:extLst>
               <p:ext uri="{D42A27DB-BD31-4B8C-83A1-F6EECF244321}">
-                <p14:modId xmlns:p14="http://schemas.microsoft.com/office/powerpoint/2010/main" val="4110088248"/>
+                <p14:modId xmlns:p14="http://schemas.microsoft.com/office/powerpoint/2010/main" val="1212596527"/>
               </p:ext>
             </p:extLst>
           </p:nvPr>
@@ -7352,7 +7352,7 @@
           <a:graphicData uri="http://schemas.openxmlformats.org/presentationml/2006/ole">
             <mc:AlternateContent xmlns:mc="http://schemas.openxmlformats.org/markup-compatibility/2006">
               <mc:Choice xmlns:v="urn:schemas-microsoft-com:vml" Requires="v">
-                <p:oleObj spid="_x0000_s1026" name="Document" showAsIcon="1" r:id="rId21" imgW="914400" imgH="771480" progId="Word.Document.12">
+                <p:oleObj spid="_x0000_s1028" name="Document" showAsIcon="1" r:id="rId21" imgW="914400" imgH="771480" progId="Word.Document.12">
                   <p:link updateAutomatic="1"/>
                 </p:oleObj>
               </mc:Choice>

</xml_diff>